<commit_message>
docs: correct architecture and exception claims, rebuild report, slides and zip
Co-Authored-By: Claude Opus 5.5 <noreply@anthropic.com>
</commit_message>
<xml_diff>
--- a/deliverables/Demo_Slides.pptx
+++ b/deliverables/Demo_Slides.pptx
@@ -4739,7 +4739,7 @@
                 </a:solidFill>
                 <a:latin typeface="Cambria"/>
               </a:rPr>
-              <a:t>100</a:t>
+              <a:t>161</a:t>
             </a:r>
           </a:p>
         </p:txBody>
@@ -4863,7 +4863,7 @@
                 </a:solidFill>
                 <a:latin typeface="Cambria"/>
               </a:rPr>
-              <a:t>97 %</a:t>
+              <a:t>98 %</a:t>
             </a:r>
           </a:p>
         </p:txBody>
@@ -9341,7 +9341,7 @@
                 </a:solidFill>
                 <a:latin typeface="Calibri"/>
               </a:rPr>
-              <a:t>Screenshots found bugs that 100 passing unit tests did not.</a:t>
+              <a:t>Screenshots found bugs that the passing unit tests did not.</a:t>
             </a:r>
           </a:p>
         </p:txBody>
@@ -9547,7 +9547,7 @@
                 </a:solidFill>
                 <a:latin typeface="Calibri"/>
               </a:rPr>
-              <a:t>100 tests, 97 % coverage, ruff-clean code, graceful error handling.</a:t>
+              <a:t>161 tests, 98 % coverage, ruff-clean code, graceful error handling.</a:t>
             </a:r>
           </a:p>
           <a:p>

</xml_diff>

<commit_message>
fix: format negative net savings, escape dollar signs in chart names, final deliverables
Co-Authored-By: Claude Opus 5.5 <noreply@anthropic.com>
</commit_message>
<xml_diff>
--- a/deliverables/Demo_Slides.pptx
+++ b/deliverables/Demo_Slides.pptx
@@ -4739,7 +4739,7 @@
                 </a:solidFill>
                 <a:latin typeface="Cambria"/>
               </a:rPr>
-              <a:t>161</a:t>
+              <a:t>163</a:t>
             </a:r>
           </a:p>
         </p:txBody>
@@ -6284,7 +6284,7 @@
                 </a:solidFill>
                 <a:latin typeface="Calibri"/>
               </a:rPr>
-              <a:t>No logic lives in the UI, so it is unit tested without a screen.</a:t>
+              <a:t>Business rules live outside the UI, so they are unit tested without a screen.</a:t>
             </a:r>
           </a:p>
           <a:p>
@@ -9547,7 +9547,7 @@
                 </a:solidFill>
                 <a:latin typeface="Calibri"/>
               </a:rPr>
-              <a:t>161 tests, 98 % coverage, ruff-clean code, graceful error handling.</a:t>
+              <a:t>163 tests, 98 % coverage, ruff-clean code, graceful error handling.</a:t>
             </a:r>
           </a:p>
           <a:p>

</xml_diff>

<commit_message>
docs: regenerate report, slides and source zip with name fill-in field
Co-Authored-By: Claude Opus 5.5 <noreply@anthropic.com>
</commit_message>
<xml_diff>
--- a/deliverables/Demo_Slides.pptx
+++ b/deliverables/Demo_Slides.pptx
@@ -4194,7 +4194,7 @@
                 </a:solidFill>
                 <a:latin typeface="Calibri"/>
               </a:rPr>
-              <a:t>[Student Name] · [Date]</a:t>
+              <a:t>Student Name: ______________________ · September 30, 2026</a:t>
             </a:r>
           </a:p>
         </p:txBody>
@@ -4739,7 +4739,7 @@
                 </a:solidFill>
                 <a:latin typeface="Cambria"/>
               </a:rPr>
-              <a:t>163</a:t>
+              <a:t>173</a:t>
             </a:r>
           </a:p>
         </p:txBody>
@@ -9547,7 +9547,7 @@
                 </a:solidFill>
                 <a:latin typeface="Calibri"/>
               </a:rPr>
-              <a:t>163 tests, 98 % coverage, ruff-clean code, graceful error handling.</a:t>
+              <a:t>173 tests, 98 % coverage, ruff-clean code, graceful error handling.</a:t>
             </a:r>
           </a:p>
           <a:p>

</xml_diff>

<commit_message>
docs: document the LaTeX build in README, refresh slides and source zip
Co-Authored-By: Claude Opus 5.5 <noreply@anthropic.com>
</commit_message>
<xml_diff>
--- a/deliverables/Demo_Slides.pptx
+++ b/deliverables/Demo_Slides.pptx
@@ -4194,7 +4194,7 @@
                 </a:solidFill>
                 <a:latin typeface="Calibri"/>
               </a:rPr>
-              <a:t>Student Name: ______________________ · September 30, 2026</a:t>
+              <a:t>Student Name: ______________________ · October 1, 2026</a:t>
             </a:r>
           </a:p>
         </p:txBody>
@@ -4215,8 +4215,8 @@
         </p:blipFill>
         <p:spPr>
           <a:xfrm>
-            <a:off x="6583680" y="1490662"/>
-            <a:ext cx="5074920" cy="3876674"/>
+            <a:off x="6583680" y="1843087"/>
+            <a:ext cx="5074920" cy="3171825"/>
           </a:xfrm>
           <a:prstGeom prst="rect">
             <a:avLst/>
@@ -4739,7 +4739,7 @@
                 </a:solidFill>
                 <a:latin typeface="Cambria"/>
               </a:rPr>
-              <a:t>173</a:t>
+              <a:t>175</a:t>
             </a:r>
           </a:p>
         </p:txBody>
@@ -6050,8 +6050,8 @@
         </p:blipFill>
         <p:spPr>
           <a:xfrm>
-            <a:off x="7223760" y="1512212"/>
-            <a:ext cx="4434840" cy="3010614"/>
+            <a:off x="7223760" y="1660483"/>
+            <a:ext cx="4434840" cy="2714073"/>
           </a:xfrm>
           <a:prstGeom prst="rect">
             <a:avLst/>
@@ -9348,7 +9348,7 @@
       </p:sp>
       <p:pic>
         <p:nvPicPr>
-          <p:cNvPr id="15" name="Picture 14" descr="cli_summary.png"/>
+          <p:cNvPr id="15" name="Picture 14" descr="cli_session_summary.png"/>
           <p:cNvPicPr>
             <a:picLocks noChangeAspect="1"/>
           </p:cNvPicPr>
@@ -9362,8 +9362,8 @@
         </p:blipFill>
         <p:spPr>
           <a:xfrm>
-            <a:off x="6858000" y="1579626"/>
-            <a:ext cx="4800600" cy="3607308"/>
+            <a:off x="6858000" y="2245173"/>
+            <a:ext cx="4800600" cy="2276213"/>
           </a:xfrm>
           <a:prstGeom prst="rect">
             <a:avLst/>
@@ -9547,7 +9547,7 @@
                 </a:solidFill>
                 <a:latin typeface="Calibri"/>
               </a:rPr>
-              <a:t>173 tests, 98 % coverage, ruff-clean code, graceful error handling.</a:t>
+              <a:t>175 tests, 98 % coverage, ruff-clean code, graceful error handling.</a:t>
             </a:r>
           </a:p>
           <a:p>

</xml_diff>